<commit_message>
Deck: fix two wrapping box titles on the architecture slides
Co-Authored-By: Claude Fable 5.1 <noreply@anthropic.com>
Claude-Session: https://claude.ai/code/session_01GS33bizZscBMJg8sFQUe9h
</commit_message>
<xml_diff>
--- a/deck/Nabd.pptx
+++ b/deck/Nabd.pptx
@@ -10301,7 +10301,7 @@
                 <a:ea typeface="Arial" pitchFamily="34" charset="-122"/>
                 <a:cs typeface="Arial" pitchFamily="34" charset="-120"/>
               </a:rPr>
-              <a:t>Analytical warehouse</a:t>
+              <a:t>Warehouse</a:t>
             </a:r>
             <a:endParaRPr lang="en-US" sz="1000" dirty="0"/>
           </a:p>
@@ -10343,7 +10343,7 @@
                 <a:ea typeface="Arial" pitchFamily="34" charset="-122"/>
                 <a:cs typeface="Arial" pitchFamily="34" charset="-120"/>
               </a:rPr>
-              <a:t>streaming export · curated marts · in-warehouse ML</a:t>
+              <a:t>analytical store · streaming export · curated marts · in-warehouse ML</a:t>
             </a:r>
             <a:endParaRPr lang="en-US" sz="750" dirty="0"/>
           </a:p>
@@ -12114,46 +12114,7 @@
       </p:sp>
       <p:sp>
         <p:nvSpPr>
-          <p:cNvPr id="78" name="Text 69"/>
-          <p:cNvSpPr txBox="1"/>
-          <p:nvPr/>
-        </p:nvSpPr>
-        <p:spPr>
-          <a:xfrm>
-            <a:off x="5760720" y="3547872"/>
-            <a:ext cx="868680" cy="182880"/>
-          </a:xfrm>
-          <a:prstGeom prst="rect">
-            <a:avLst/>
-          </a:prstGeom>
-          <a:noFill/>
-          <a:ln/>
-        </p:spPr>
-        <p:txBody>
-          <a:bodyPr wrap="square" lIns="0" tIns="0" rIns="0" bIns="0" rtlCol="0" anchor="t"/>
-          <a:lstStyle/>
-          <a:p>
-            <a:pPr algn="ctr" indent="0" marL="0">
-              <a:buNone/>
-            </a:pPr>
-            <a:r>
-              <a:rPr lang="en-US" sz="700" dirty="0">
-                <a:solidFill>
-                  <a:srgbClr val="1A73E8"/>
-                </a:solidFill>
-                <a:latin typeface="Arial" pitchFamily="34" charset="0"/>
-                <a:ea typeface="Arial" pitchFamily="34" charset="-122"/>
-                <a:cs typeface="Arial" pitchFamily="34" charset="-120"/>
-              </a:rPr>
-              <a:t>data and models</a:t>
-            </a:r>
-            <a:endParaRPr lang="en-US" sz="700" dirty="0"/>
-          </a:p>
-        </p:txBody>
-      </p:sp>
-      <p:sp>
-        <p:nvSpPr>
-          <p:cNvPr id="79" name="Shape 70"/>
+          <p:cNvPr id="78" name="Shape 69"/>
           <p:cNvSpPr/>
           <p:nvPr/>
         </p:nvSpPr>
@@ -12180,7 +12141,7 @@
       </p:sp>
       <p:pic>
         <p:nvPicPr>
-          <p:cNvPr id="80" name="Image 7" descr="preencoded.png">    </p:cNvPr>
+          <p:cNvPr id="79" name="Image 7" descr="preencoded.png">    </p:cNvPr>
           <p:cNvPicPr>
             <a:picLocks noChangeAspect="1"/>
           </p:cNvPicPr>
@@ -12204,7 +12165,7 @@
       </p:pic>
       <p:sp>
         <p:nvSpPr>
-          <p:cNvPr id="81" name="Text 71"/>
+          <p:cNvPr id="80" name="Text 70"/>
           <p:cNvSpPr txBox="1"/>
           <p:nvPr/>
         </p:nvSpPr>
@@ -12263,7 +12224,7 @@
       </p:sp>
       <p:sp>
         <p:nvSpPr>
-          <p:cNvPr id="82" name="Text 72"/>
+          <p:cNvPr id="81" name="Text 71"/>
           <p:cNvSpPr txBox="1"/>
           <p:nvPr/>
         </p:nvSpPr>
@@ -12302,7 +12263,7 @@
       </p:sp>
       <p:sp>
         <p:nvSpPr>
-          <p:cNvPr id="83" name="Text 73"/>
+          <p:cNvPr id="82" name="Text 72"/>
           <p:cNvSpPr txBox="1"/>
           <p:nvPr/>
         </p:nvSpPr>
@@ -12881,7 +12842,7 @@
                 <a:ea typeface="Arial" pitchFamily="34" charset="-122"/>
                 <a:cs typeface="Arial" pitchFamily="34" charset="-120"/>
               </a:rPr>
-              <a:t>App and API (serverless)</a:t>
+              <a:t>App and API</a:t>
             </a:r>
             <a:endParaRPr lang="en-US" sz="950" dirty="0"/>
           </a:p>
@@ -12923,7 +12884,7 @@
                 <a:ea typeface="Arial" pitchFamily="34" charset="-122"/>
                 <a:cs typeface="Arial" pitchFamily="34" charset="-120"/>
               </a:rPr>
-              <a:t>web front end · API · streams the agent trace to the browser</a:t>
+              <a:t>serverless web front end and API · streams the agent trace to the browser</a:t>
             </a:r>
             <a:endParaRPr lang="en-US" sz="750" dirty="0"/>
           </a:p>
@@ -13897,7 +13858,7 @@
                 <a:ea typeface="Arial" pitchFamily="34" charset="-122"/>
                 <a:cs typeface="Arial" pitchFamily="34" charset="-120"/>
               </a:rPr>
-              <a:t>Streaming export to the warehouse</a:t>
+              <a:t>Warehouse export</a:t>
             </a:r>
             <a:endParaRPr lang="en-US" sz="950" dirty="0"/>
           </a:p>

</xml_diff>